<commit_message>
Update Group 11 course materials and launch guidance
</commit_message>
<xml_diff>
--- a/group11_presentation.pptx
+++ b/group11_presentation.pptx
@@ -2,17 +2,17 @@
 <file path=ppt/presentation.xml><?xml version="1.0" encoding="utf-8"?>
 <p:presentation xmlns:p="http://schemas.openxmlformats.org/presentationml/2006/main">
   <p:sldMasterIdLst>
-    <p:sldMasterId xmlns:r="http://schemas.openxmlformats.org/officeDocument/2006/relationships" id="2147483648" r:id="R60fe640133804845"/>
+    <p:sldMasterId xmlns:r="http://schemas.openxmlformats.org/officeDocument/2006/relationships" id="2147483648" r:id="Recf5efb28d8d4a03"/>
   </p:sldMasterIdLst>
   <p:notesMasterIdLst>
-    <p:notesMasterId xmlns:r="http://schemas.openxmlformats.org/officeDocument/2006/relationships" r:id="R2c7f80560a2042f3"/>
+    <p:notesMasterId xmlns:r="http://schemas.openxmlformats.org/officeDocument/2006/relationships" r:id="R0ef639d550da4107"/>
   </p:notesMasterIdLst>
   <p:sldIdLst>
-    <p:sldId xmlns:r="http://schemas.openxmlformats.org/officeDocument/2006/relationships" id="256" r:id="R9ecca29500de4705"/>
-    <p:sldId xmlns:r="http://schemas.openxmlformats.org/officeDocument/2006/relationships" id="257" r:id="R181b4ea6fe534242"/>
-    <p:sldId xmlns:r="http://schemas.openxmlformats.org/officeDocument/2006/relationships" id="258" r:id="R93da92512473441a"/>
-    <p:sldId xmlns:r="http://schemas.openxmlformats.org/officeDocument/2006/relationships" id="259" r:id="Ra03e880f642c43a7"/>
-    <p:sldId xmlns:r="http://schemas.openxmlformats.org/officeDocument/2006/relationships" id="260" r:id="R1fcf81a34d53449c"/>
+    <p:sldId xmlns:r="http://schemas.openxmlformats.org/officeDocument/2006/relationships" id="256" r:id="Re4b809ef57814ad2"/>
+    <p:sldId xmlns:r="http://schemas.openxmlformats.org/officeDocument/2006/relationships" id="257" r:id="R2afe403116014f41"/>
+    <p:sldId xmlns:r="http://schemas.openxmlformats.org/officeDocument/2006/relationships" id="258" r:id="R8905568e7e8a4743"/>
+    <p:sldId xmlns:r="http://schemas.openxmlformats.org/officeDocument/2006/relationships" id="259" r:id="R370f525f11ca4639"/>
+    <p:sldId xmlns:r="http://schemas.openxmlformats.org/officeDocument/2006/relationships" id="260" r:id="Rc2fdad650ea544a8"/>
   </p:sldIdLst>
   <p:sldSz cx="12192000" cy="6858000"/>
   <p:notesSz cx="6858000" cy="9144000"/>
@@ -446,7 +446,27 @@
           <a:lstStyle xmlns:a="http://schemas.openxmlformats.org/drawingml/2006/main"/>
           <a:p xmlns:a="http://schemas.openxmlformats.org/drawingml/2006/main">
             <a:r>
-              <a:t>Time: 0:00-1:00. Explain the practical problem and show the local application. Core functionality remains available without AI. Screenshot uses an explicitly fictional candidate and fictional sample jobs. Sources: project README.md and working application. Group identification can be added after the group number and members are confirmed.</a:t>
+              <a:t>### Slide 1 from 00 to 01 minute</a:t>
+            </a:r>
+          </a:p>
+          <a:p xmlns:a="http://schemas.openxmlformats.org/drawingml/2006/main">
+            <a:r>
+              <a:t/>
+            </a:r>
+          </a:p>
+          <a:p xmlns:a="http://schemas.openxmlformats.org/drawingml/2006/main">
+            <a:r>
+              <a:t>Good afternoon. We are Group 11, and our project is JobCompass, a local Python application for resume-based job discovery. Job seekers often switch between several websites, compare inconsistent descriptions and maintain separate application notes. Our application brings those activities into one workflow. A user imports a resume, checks recognized skills and compares jobs with visible reasons for each score. The application also records saved jobs and application progress. Optional DeepSeek assistance can suggest clearer resume wording. The interface runs in the browser, while Python and SQLite run on the same computer. We start main.py and open the local address rather than opening the HTML file directly. The demonstration uses a fictional resume.</a:t>
+            </a:r>
+          </a:p>
+          <a:p xmlns:a="http://schemas.openxmlformats.org/drawingml/2006/main">
+            <a:r>
+              <a:t/>
+            </a:r>
+          </a:p>
+          <a:p xmlns:a="http://schemas.openxmlformats.org/drawingml/2006/main">
+            <a:r>
+              <a:t>Sources: README.md and the independent fictional-resume demo database. Screenshot total 6,920 = 6,908 imported JobsDB jobs + 12 fictional samples.</a:t>
             </a:r>
           </a:p>
         </p:txBody>
@@ -516,7 +536,27 @@
           <a:lstStyle xmlns:a="http://schemas.openxmlformats.org/drawingml/2006/main"/>
           <a:p xmlns:a="http://schemas.openxmlformats.org/drawingml/2006/main">
             <a:r>
-              <a:t>Time: 1:00-2:00. Describe separation of responsibilities and why it improves testability. A bounded ThreadPoolExecutor keeps external network operations away from the request flow. SQLite uses parameterized SQL and independent connections. Source: jobcompass modules and docs/SPECIFICATION.md.</a:t>
+              <a:t>### Slide 2 from 01 to 02 minutes</a:t>
+            </a:r>
+          </a:p>
+          <a:p xmlns:a="http://schemas.openxmlformats.org/drawingml/2006/main">
+            <a:r>
+              <a:t/>
+            </a:r>
+          </a:p>
+          <a:p xmlns:a="http://schemas.openxmlformats.org/drawingml/2006/main">
+            <a:r>
+              <a:t>The implementation separates responsibilities into Python modules. Resume processing uses regular expressions and file readers. Data-source modules normalize public API records and local imports. A separate benchmark module processes the research archive and produces a reproducible compressed dataset. The matching module uses weighted F1 and TF-IDF similarity. SQLite stores jobs and application records with parameterized SQL and transactions. The HTTP layer exposes the interface and starts bounded background tasks for collection and AI calls. This design makes behavior easier to test without contacting an external service. It demonstrates functions, classes, modules, file input, data structures, networking, persistence, specification and testing. Secrets stay in local configuration and do not enter the submitted package.</a:t>
+            </a:r>
+          </a:p>
+          <a:p xmlns:a="http://schemas.openxmlformats.org/drawingml/2006/main">
+            <a:r>
+              <a:t/>
+            </a:r>
+          </a:p>
+          <a:p xmlns:a="http://schemas.openxmlformats.org/drawingml/2006/main">
+            <a:r>
+              <a:t>Sources: jobcompass modules, docs/SPECIFICATION.md and tests.</a:t>
             </a:r>
           </a:p>
         </p:txBody>
@@ -586,7 +626,27 @@
           <a:lstStyle xmlns:a="http://schemas.openxmlformats.org/drawingml/2006/main"/>
           <a:p xmlns:a="http://schemas.openxmlformats.org/drawingml/2006/main">
             <a:r>
-              <a:t>Time: 2:00-3:00. Show the two verified external sources and explain that data collection does not send the resume. Distinguish live sources from twelve fictional demo jobs. No claim is made to scrape authenticated domestic recruitment sites. Sources: docs/live_check.json, https://github.com/remotive-com/remote-jobs-api and https://www.arbeitnow.com/blog/job-board-api. Counts describe this test, not permanent availability.</a:t>
+              <a:t>### Slide 3 from 02 to 03 minutes</a:t>
+            </a:r>
+          </a:p>
+          <a:p xmlns:a="http://schemas.openxmlformats.org/drawingml/2006/main">
+            <a:r>
+              <a:t/>
+            </a:r>
+          </a:p>
+          <a:p xmlns:a="http://schemas.openxmlformats.org/drawingml/2006/main">
+            <a:r>
+              <a:t>The project supports two live public integrations, Remotive and Arbeitnow. It also integrates an existing JobsDB research archive from the group's collection, dated 28 September 2026. We read that archive locally rather than claim a new live JobsDB scraper. It contains 6,939 input records. Validation accepts 6,910 and rejects 29 with invalid or missing required data. The app imports 6,908 because two records were already marked expired. Cleaning removes HTML and tracking objects, retains canonical job links and masks common contact text. The manifest records checksums so the input and output can be identified. These are historical vacancies. Their presence in the research dataset does not guarantee that an employer is still recruiting.</a:t>
+            </a:r>
+          </a:p>
+          <a:p xmlns:a="http://schemas.openxmlformats.org/drawingml/2006/main">
+            <a:r>
+              <a:t/>
+            </a:r>
+          </a:p>
+          <a:p xmlns:a="http://schemas.openxmlformats.org/drawingml/2006/main">
+            <a:r>
+              <a:t>Sources: data/benchmark/jobsdb_20260928.manifest.json and docs/BENCHMARK.md. Earlier live API check counts are historical, not permanent availability.</a:t>
             </a:r>
           </a:p>
         </p:txBody>
@@ -656,7 +716,27 @@
           <a:lstStyle xmlns:a="http://schemas.openxmlformats.org/drawingml/2006/main"/>
           <a:p xmlns:a="http://schemas.openxmlformats.org/drawingml/2006/main">
             <a:r>
-              <a:t>Time: 3:00-4:00. Explain weighted precision and recall, cosine similarity, active-weight normalization and condition coverage. The generic-skills regression test catches unrelated writing jobs. AI calls require opt-in, use saved resume content and retain the original resume. Sources: matching.py, ai.py, docs/SPECIFICATION.md and https://api-docs.deepseek.com/guides/json_mode/.</a:t>
+              <a:t>### Slide 4 from 03 to 04 minutes</a:t>
+            </a:r>
+          </a:p>
+          <a:p xmlns:a="http://schemas.openxmlformats.org/drawingml/2006/main">
+            <a:r>
+              <a:t/>
+            </a:r>
+          </a:p>
+          <a:p xmlns:a="http://schemas.openxmlformats.org/drawingml/2006/main">
+            <a:r>
+              <a:t>The matching score has five components. Skills contribute a base weight of 45 percent, text 25 percent, experience 15 percent, location 10 percent and education 5 percent. Skill matching uses weighted precision and recall, so a generic skill alone has limited influence. Unknown requirements leave the active denominator, and the interface displays coverage. TF-IDF depends on the current job corpus, so scores can change when more jobs enter the database. Each job detail shows matched skills and gaps for human inspection. DeepSeek supplies explanations and a separate resume draft after user authorization. It does not set the numeric ranking score. The score helps prioritize investigation and cannot represent a hiring probability.</a:t>
+            </a:r>
+          </a:p>
+          <a:p xmlns:a="http://schemas.openxmlformats.org/drawingml/2006/main">
+            <a:r>
+              <a:t/>
+            </a:r>
+          </a:p>
+          <a:p xmlns:a="http://schemas.openxmlformats.org/drawingml/2006/main">
+            <a:r>
+              <a:t>Sources: jobcompass/matching.py, ai.py and docs/SPECIFICATION.md. Base weights 45, 25, 15, 10, 5. Unknown conditions leave the denominator.</a:t>
             </a:r>
           </a:p>
         </p:txBody>
@@ -726,7 +806,27 @@
           <a:lstStyle xmlns:a="http://schemas.openxmlformats.org/drawingml/2006/main"/>
           <a:p xmlns:a="http://schemas.openxmlformats.org/drawingml/2006/main">
             <a:r>
-              <a:t>Time: 4:00-5:00. Summarize validation honestly. The benchmark is a local run of repeated sample jobs; it is not a production performance guarantee. Show an invalid-input error if time permits. Explain that Codex assisted specification, implementation, tests, review and documentation. Each member must independently understand and report their real contributions. Sources: docs/test_results.txt, docs/evaluation.json, docs/live_check.json, docs/DEMO_SCRIPT.md.</a:t>
+              <a:t>### Slide 5 from 04 to 05 minutes</a:t>
+            </a:r>
+          </a:p>
+          <a:p xmlns:a="http://schemas.openxmlformats.org/drawingml/2006/main">
+            <a:r>
+              <a:t/>
+            </a:r>
+          </a:p>
+          <a:p xmlns:a="http://schemas.openxmlformats.org/drawingml/2006/main">
+            <a:r>
+              <a:t>The current version passes 71 local automated tests. These cover invalid inputs, persistence, matching, request boundaries and the research import pipeline. The real-data benchmark ranks 6,910 accepted JobsDB records for a fictional resume. Its recorded median is 4.0517 seconds across three local runs. This measures ranking runtime only. There are no human relevance labels, so we do not claim real-data accuracy, recall or NDCG. The separate synthetic fixture has twelve authored jobs and only demonstrates expected sample behavior. Our demonstration shows the resume evidence, a score breakdown and a saved application record. Codex assisted implementation and documentation. Each member must verify the project and report their own actual contributions. Independent relevance annotation is a future improvement.</a:t>
+            </a:r>
+          </a:p>
+          <a:p xmlns:a="http://schemas.openxmlformats.org/drawingml/2006/main">
+            <a:r>
+              <a:t/>
+            </a:r>
+          </a:p>
+          <a:p xmlns:a="http://schemas.openxmlformats.org/drawingml/2006/main">
+            <a:r>
+              <a:t>Sources: docs/test_results.txt and docs/benchmark_jobsdb.json. Timing on macOS with Python 3.8.10 excludes import and browser rendering. Cloud CI does not execute inside the published ZIP.</a:t>
             </a:r>
           </a:p>
         </p:txBody>
@@ -794,7 +894,7 @@
   </p:cSld>
   <p:clrMap bg1="lt1" tx1="dk1" bg2="lt2" tx2="dk2" accent1="accent1" accent2="accent2" accent3="accent3" accent4="accent4" accent5="accent5" accent6="accent6" hlink="hlink" folHlink="folHlink"/>
   <p:sldLayoutIdLst>
-    <p:sldLayoutId xmlns:r="http://schemas.openxmlformats.org/officeDocument/2006/relationships" id="2147483649" r:id="Rb3e4a40b4e1a486b"/>
+    <p:sldLayoutId xmlns:r="http://schemas.openxmlformats.org/officeDocument/2006/relationships" id="2147483649" r:id="R5c0508a4380247cc"/>
   </p:sldLayoutIdLst>
   <p:txStyles>
     <p:titleStyle>
@@ -1550,6 +1650,7 @@
           <a:lstStyle xmlns:a="http://schemas.openxmlformats.org/drawingml/2006/main"/>
           <a:p xmlns:a="http://schemas.openxmlformats.org/drawingml/2006/main">
             <a:pPr>
+              <a:buNone/>
               <a:defRPr sz="3000" b="1">
                 <a:solidFill>
                   <a:srgbClr val="183C3B"/>
@@ -1607,6 +1708,7 @@
           <a:lstStyle xmlns:a="http://schemas.openxmlformats.org/drawingml/2006/main"/>
           <a:p xmlns:a="http://schemas.openxmlformats.org/drawingml/2006/main">
             <a:pPr>
+              <a:buNone/>
               <a:defRPr sz="1050" b="0">
                 <a:solidFill>
                   <a:srgbClr val="6C7D82"/>
@@ -1625,7 +1727,7 @@
                 <a:ea typeface="Helvetica Neue"/>
                 <a:cs typeface="Helvetica Neue"/>
               </a:rPr>
-              <a:t>JobCompass    INT6181    1 / 5</a:t>
+              <a:t>Group 11    INT6181    1 / 5</a:t>
             </a:r>
           </a:p>
         </p:txBody>
@@ -1664,7 +1766,8 @@
           <a:lstStyle xmlns:a="http://schemas.openxmlformats.org/drawingml/2006/main"/>
           <a:p xmlns:a="http://schemas.openxmlformats.org/drawingml/2006/main">
             <a:pPr>
-              <a:defRPr sz="2025" b="0">
+              <a:buNone/>
+              <a:defRPr sz="1500" b="0">
                 <a:solidFill>
                   <a:srgbClr val="6C7D82"/>
                 </a:solidFill>
@@ -1674,7 +1777,7 @@
               </a:defRPr>
             </a:pPr>
             <a:r>
-              <a:rPr sz="2025" b="0">
+              <a:rPr sz="1500" b="0">
                 <a:solidFill>
                   <a:srgbClr val="6C7D82"/>
                 </a:solidFill>
@@ -1682,7 +1785,7 @@
                 <a:ea typeface="Helvetica Neue"/>
                 <a:cs typeface="Helvetica Neue"/>
               </a:rPr>
-              <a:t>A local Python workspace for resume-based job discovery</a:t>
+              <a:t>OU JUNHANG, ZHANG XIQIAN, JIANG YIFAN, CAI SHANGHENG, GUO ZHENGKUN</a:t>
             </a:r>
           </a:p>
         </p:txBody>
@@ -1721,6 +1824,7 @@
           <a:lstStyle xmlns:a="http://schemas.openxmlformats.org/drawingml/2006/main"/>
           <a:p xmlns:a="http://schemas.openxmlformats.org/drawingml/2006/main">
             <a:pPr>
+              <a:buNone/>
               <a:defRPr sz="2025" b="1">
                 <a:solidFill>
                   <a:srgbClr val="183C3B"/>
@@ -1778,6 +1882,7 @@
           <a:lstStyle xmlns:a="http://schemas.openxmlformats.org/drawingml/2006/main"/>
           <a:p xmlns:a="http://schemas.openxmlformats.org/drawingml/2006/main">
             <a:pPr>
+              <a:buNone/>
               <a:defRPr sz="1875" b="0">
                 <a:solidFill>
                   <a:srgbClr val="183C3B"/>
@@ -1801,6 +1906,7 @@
           </a:p>
           <a:p xmlns:a="http://schemas.openxmlformats.org/drawingml/2006/main">
             <a:pPr>
+              <a:buNone/>
               <a:defRPr sz="1875" b="0">
                 <a:solidFill>
                   <a:srgbClr val="183C3B"/>
@@ -1824,6 +1930,7 @@
           </a:p>
           <a:p xmlns:a="http://schemas.openxmlformats.org/drawingml/2006/main">
             <a:pPr>
+              <a:buNone/>
               <a:defRPr sz="1875" b="0">
                 <a:solidFill>
                   <a:srgbClr val="183C3B"/>
@@ -1881,6 +1988,7 @@
           <a:lstStyle xmlns:a="http://schemas.openxmlformats.org/drawingml/2006/main"/>
           <a:p xmlns:a="http://schemas.openxmlformats.org/drawingml/2006/main">
             <a:pPr>
+              <a:buNone/>
               <a:defRPr sz="2025" b="1">
                 <a:solidFill>
                   <a:srgbClr val="183C3B"/>
@@ -1938,7 +2046,8 @@
           <a:lstStyle xmlns:a="http://schemas.openxmlformats.org/drawingml/2006/main"/>
           <a:p xmlns:a="http://schemas.openxmlformats.org/drawingml/2006/main">
             <a:pPr>
-              <a:defRPr sz="1875" b="0">
+              <a:buNone/>
+              <a:defRPr sz="1725" b="0">
                 <a:solidFill>
                   <a:srgbClr val="183C3B"/>
                 </a:solidFill>
@@ -1948,7 +2057,7 @@
               </a:defRPr>
             </a:pPr>
             <a:r>
-              <a:rPr sz="1875" b="0">
+              <a:rPr sz="1725" b="0">
                 <a:solidFill>
                   <a:srgbClr val="183C3B"/>
                 </a:solidFill>
@@ -1956,27 +2065,29 @@
                 <a:ea typeface="Helvetica Neue"/>
                 <a:cs typeface="Helvetica Neue"/>
               </a:rPr>
-              <a:t>Import a resume, compare jobs and record the next step.</a:t>
+              <a:t>Start main.py and open
+http://127.0.0.1:8765/
+Import, compare and track jobs.</a:t>
             </a:r>
           </a:p>
         </p:txBody>
       </p:sp>
       <p:pic>
         <p:nvPicPr>
-          <p:cNvPr id="16" name=""/>
+          <p:cNvPr id="18" name=""/>
           <p:cNvPicPr>
             <a:picLocks xmlns:a="http://schemas.openxmlformats.org/drawingml/2006/main" noChangeAspect="1"/>
           </p:cNvPicPr>
           <p:nvPr/>
         </p:nvPicPr>
         <p:blipFill>
-          <a:blip xmlns:r="http://schemas.openxmlformats.org/officeDocument/2006/relationships" xmlns:a="http://schemas.openxmlformats.org/drawingml/2006/main" r:embed="Ra4aa475f65b043b2"/>
+          <a:blip xmlns:r="http://schemas.openxmlformats.org/officeDocument/2006/relationships" xmlns:a="http://schemas.openxmlformats.org/drawingml/2006/main" r:embed="Raff0a9d60cba4a96"/>
           <a:stretch xmlns:a="http://schemas.openxmlformats.org/drawingml/2006/main"/>
         </p:blipFill>
         <p:spPr>
           <a:xfrm xmlns:a="http://schemas.openxmlformats.org/drawingml/2006/main">
-            <a:off x="4957763" y="1762125"/>
-            <a:ext cx="6515100" cy="4524375"/>
+            <a:off x="4954058" y="2047875"/>
+            <a:ext cx="6570133" cy="3695700"/>
           </a:xfrm>
           <a:prstGeom xmlns:a="http://schemas.openxmlformats.org/drawingml/2006/main" prst="rect">
             <a:avLst/>
@@ -2046,6 +2157,7 @@
           <a:lstStyle xmlns:a="http://schemas.openxmlformats.org/drawingml/2006/main"/>
           <a:p xmlns:a="http://schemas.openxmlformats.org/drawingml/2006/main">
             <a:pPr>
+              <a:buNone/>
               <a:defRPr sz="3000" b="1">
                 <a:solidFill>
                   <a:srgbClr val="183C3B"/>
@@ -2103,6 +2215,7 @@
           <a:lstStyle xmlns:a="http://schemas.openxmlformats.org/drawingml/2006/main"/>
           <a:p xmlns:a="http://schemas.openxmlformats.org/drawingml/2006/main">
             <a:pPr>
+              <a:buNone/>
               <a:defRPr sz="1050" b="0">
                 <a:solidFill>
                   <a:srgbClr val="6C7D82"/>
@@ -2121,7 +2234,7 @@
                 <a:ea typeface="Helvetica Neue"/>
                 <a:cs typeface="Helvetica Neue"/>
               </a:rPr>
-              <a:t>JobCompass    INT6181    2 / 5</a:t>
+              <a:t>Group 11    INT6181    2 / 5</a:t>
             </a:r>
           </a:p>
         </p:txBody>
@@ -2160,6 +2273,7 @@
           <a:lstStyle xmlns:a="http://schemas.openxmlformats.org/drawingml/2006/main"/>
           <a:p xmlns:a="http://schemas.openxmlformats.org/drawingml/2006/main">
             <a:pPr>
+              <a:buNone/>
               <a:defRPr sz="1950" b="0">
                 <a:solidFill>
                   <a:srgbClr val="6C7D82"/>
@@ -2185,7 +2299,7 @@
       </p:sp>
       <p:graphicFrame>
         <p:nvGraphicFramePr>
-          <p:cNvPr id="9" name=""/>
+          <p:cNvPr id="11" name=""/>
           <p:cNvGraphicFramePr/>
           <p:nvPr/>
         </p:nvGraphicFramePr>
@@ -2684,6 +2798,7 @@
           <a:lstStyle xmlns:a="http://schemas.openxmlformats.org/drawingml/2006/main"/>
           <a:p xmlns:a="http://schemas.openxmlformats.org/drawingml/2006/main">
             <a:pPr>
+              <a:buNone/>
               <a:defRPr sz="1725" b="0">
                 <a:solidFill>
                   <a:srgbClr val="6C7D82"/>
@@ -2702,7 +2817,7 @@
                 <a:ea typeface="Helvetica Neue"/>
                 <a:cs typeface="Helvetica Neue"/>
               </a:rPr>
-              <a:t>main.py is the entry point. SQLite and local ranking work offline.</a:t>
+              <a:t>benchmark.py adds ZIP validation, gzip snapshots and reproducible evaluation.</a:t>
             </a:r>
           </a:p>
         </p:txBody>
@@ -2770,6 +2885,7 @@
           <a:lstStyle xmlns:a="http://schemas.openxmlformats.org/drawingml/2006/main"/>
           <a:p xmlns:a="http://schemas.openxmlformats.org/drawingml/2006/main">
             <a:pPr>
+              <a:buNone/>
               <a:defRPr sz="3000" b="1">
                 <a:solidFill>
                   <a:srgbClr val="183C3B"/>
@@ -2788,7 +2904,7 @@
                 <a:ea typeface="Helvetica Neue"/>
                 <a:cs typeface="Helvetica Neue"/>
               </a:rPr>
-              <a:t>Public job sources and reliable imports</a:t>
+              <a:t>Public sources and JobsDB research data</a:t>
             </a:r>
           </a:p>
         </p:txBody>
@@ -2827,6 +2943,7 @@
           <a:lstStyle xmlns:a="http://schemas.openxmlformats.org/drawingml/2006/main"/>
           <a:p xmlns:a="http://schemas.openxmlformats.org/drawingml/2006/main">
             <a:pPr>
+              <a:buNone/>
               <a:defRPr sz="1050" b="0">
                 <a:solidFill>
                   <a:srgbClr val="6C7D82"/>
@@ -2845,7 +2962,7 @@
                 <a:ea typeface="Helvetica Neue"/>
                 <a:cs typeface="Helvetica Neue"/>
               </a:rPr>
-              <a:t>JobCompass    INT6181    3 / 5</a:t>
+              <a:t>Group 11    INT6181    3 / 5</a:t>
             </a:r>
           </a:p>
         </p:txBody>
@@ -2884,6 +3001,7 @@
           <a:lstStyle xmlns:a="http://schemas.openxmlformats.org/drawingml/2006/main"/>
           <a:p xmlns:a="http://schemas.openxmlformats.org/drawingml/2006/main">
             <a:pPr>
+              <a:buNone/>
               <a:defRPr sz="2100" b="1">
                 <a:solidFill>
                   <a:srgbClr val="087D75"/>
@@ -2902,7 +3020,7 @@
                 <a:ea typeface="Helvetica Neue"/>
                 <a:cs typeface="Helvetica Neue"/>
               </a:rPr>
-              <a:t>341 real jobs collected in the integration check</a:t>
+              <a:t>JobsDB snapshot dated 28 September 2026</a:t>
             </a:r>
           </a:p>
         </p:txBody>
@@ -2941,7 +3059,8 @@
           <a:lstStyle xmlns:a="http://schemas.openxmlformats.org/drawingml/2006/main"/>
           <a:p xmlns:a="http://schemas.openxmlformats.org/drawingml/2006/main">
             <a:pPr>
-              <a:defRPr sz="2550" b="1">
+              <a:buNone/>
+              <a:defRPr sz="2400" b="1">
                 <a:solidFill>
                   <a:srgbClr val="183C3B"/>
                 </a:solidFill>
@@ -2951,7 +3070,7 @@
               </a:defRPr>
             </a:pPr>
             <a:r>
-              <a:rPr sz="2550" b="1">
+              <a:rPr sz="2400" b="1">
                 <a:solidFill>
                   <a:srgbClr val="183C3B"/>
                 </a:solidFill>
@@ -2959,12 +3078,13 @@
                 <a:ea typeface="Helvetica Neue"/>
                 <a:cs typeface="Helvetica Neue"/>
               </a:rPr>
-              <a:t>16 Remotive jobs</a:t>
+              <a:t>6,910 validated jobs</a:t>
             </a:r>
           </a:p>
           <a:p xmlns:a="http://schemas.openxmlformats.org/drawingml/2006/main">
             <a:pPr>
-              <a:defRPr sz="2550" b="1">
+              <a:buNone/>
+              <a:defRPr sz="2400" b="1">
                 <a:solidFill>
                   <a:srgbClr val="183C3B"/>
                 </a:solidFill>
@@ -2974,7 +3094,7 @@
               </a:defRPr>
             </a:pPr>
             <a:r>
-              <a:rPr sz="2550" b="1">
+              <a:rPr sz="2400" b="1">
                 <a:solidFill>
                   <a:srgbClr val="183C3B"/>
                 </a:solidFill>
@@ -2982,7 +3102,7 @@
                 <a:ea typeface="Helvetica Neue"/>
                 <a:cs typeface="Helvetica Neue"/>
               </a:rPr>
-              <a:t>325 Arbeitnow jobs</a:t>
+              <a:t>6,908 imported jobs</a:t>
             </a:r>
           </a:p>
         </p:txBody>
@@ -3021,7 +3141,8 @@
           <a:lstStyle xmlns:a="http://schemas.openxmlformats.org/drawingml/2006/main"/>
           <a:p xmlns:a="http://schemas.openxmlformats.org/drawingml/2006/main">
             <a:pPr>
-              <a:defRPr sz="1800" b="0">
+              <a:buNone/>
+              <a:defRPr sz="1725" b="0">
                 <a:solidFill>
                   <a:srgbClr val="183C3B"/>
                 </a:solidFill>
@@ -3031,7 +3152,7 @@
               </a:defRPr>
             </a:pPr>
             <a:r>
-              <a:rPr sz="1800" b="0">
+              <a:rPr sz="1725" b="0">
                 <a:solidFill>
                   <a:srgbClr val="183C3B"/>
                 </a:solidFill>
@@ -3039,12 +3160,13 @@
                 <a:ea typeface="Helvetica Neue"/>
                 <a:cs typeface="Helvetica Neue"/>
               </a:rPr>
-              <a:t>Six-hour collection interval</a:t>
+              <a:t>6,939 input records</a:t>
             </a:r>
           </a:p>
           <a:p xmlns:a="http://schemas.openxmlformats.org/drawingml/2006/main">
             <a:pPr>
-              <a:defRPr sz="1800" b="0">
+              <a:buNone/>
+              <a:defRPr sz="1725" b="0">
                 <a:solidFill>
                   <a:srgbClr val="183C3B"/>
                 </a:solidFill>
@@ -3054,7 +3176,7 @@
               </a:defRPr>
             </a:pPr>
             <a:r>
-              <a:rPr sz="1800" b="0">
+              <a:rPr sz="1725" b="0">
                 <a:solidFill>
                   <a:srgbClr val="183C3B"/>
                 </a:solidFill>
@@ -3062,12 +3184,13 @@
                 <a:ea typeface="Helvetica Neue"/>
                 <a:cs typeface="Helvetica Neue"/>
               </a:rPr>
-              <a:t>Source attribution and original links</a:t>
+              <a:t>29 invalid records excluded</a:t>
             </a:r>
           </a:p>
           <a:p xmlns:a="http://schemas.openxmlformats.org/drawingml/2006/main">
             <a:pPr>
-              <a:defRPr sz="1800" b="0">
+              <a:buNone/>
+              <a:defRPr sz="1725" b="0">
                 <a:solidFill>
                   <a:srgbClr val="183C3B"/>
                 </a:solidFill>
@@ -3077,7 +3200,7 @@
               </a:defRPr>
             </a:pPr>
             <a:r>
-              <a:rPr sz="1800" b="0">
+              <a:rPr sz="1725" b="0">
                 <a:solidFill>
                   <a:srgbClr val="183C3B"/>
                 </a:solidFill>
@@ -3085,7 +3208,7 @@
                 <a:ea typeface="Helvetica Neue"/>
                 <a:cs typeface="Helvetica Neue"/>
               </a:rPr>
-              <a:t>CSV, JSON, JSON-LD and manual entry</a:t>
+              <a:t>2 expired records kept for research</a:t>
             </a:r>
           </a:p>
         </p:txBody>
@@ -3124,6 +3247,7 @@
           <a:lstStyle xmlns:a="http://schemas.openxmlformats.org/drawingml/2006/main"/>
           <a:p xmlns:a="http://schemas.openxmlformats.org/drawingml/2006/main">
             <a:pPr>
+              <a:buNone/>
               <a:defRPr sz="1575" b="0">
                 <a:solidFill>
                   <a:srgbClr val="6C7D82"/>
@@ -3142,27 +3266,27 @@
                 <a:ea typeface="Helvetica Neue"/>
                 <a:cs typeface="Helvetica Neue"/>
               </a:rPr>
-              <a:t>Geographic coverage is mainly overseas and remote. Restricted domestic sites require authorized imports.</a:t>
+              <a:t>Remotive and Arbeitnow provide public API collection. JobsDB uses a supplied historical archive.</a:t>
             </a:r>
           </a:p>
         </p:txBody>
       </p:sp>
       <p:pic>
         <p:nvPicPr>
-          <p:cNvPr id="14" name=""/>
+          <p:cNvPr id="16" name=""/>
           <p:cNvPicPr>
             <a:picLocks xmlns:a="http://schemas.openxmlformats.org/drawingml/2006/main" noChangeAspect="1"/>
           </p:cNvPicPr>
           <p:nvPr/>
         </p:nvPicPr>
         <p:blipFill>
-          <a:blip xmlns:r="http://schemas.openxmlformats.org/officeDocument/2006/relationships" xmlns:a="http://schemas.openxmlformats.org/drawingml/2006/main" r:embed="R8332ac4c44754502"/>
+          <a:blip xmlns:r="http://schemas.openxmlformats.org/officeDocument/2006/relationships" xmlns:a="http://schemas.openxmlformats.org/drawingml/2006/main" r:embed="R2d53cc53ba65424e"/>
           <a:stretch xmlns:a="http://schemas.openxmlformats.org/drawingml/2006/main"/>
         </p:blipFill>
         <p:spPr>
           <a:xfrm xmlns:a="http://schemas.openxmlformats.org/drawingml/2006/main">
-            <a:off x="5454015" y="1962150"/>
-            <a:ext cx="5760720" cy="4000500"/>
+            <a:off x="4954058" y="2047875"/>
+            <a:ext cx="6570133" cy="3695700"/>
           </a:xfrm>
           <a:prstGeom xmlns:a="http://schemas.openxmlformats.org/drawingml/2006/main" prst="rect">
             <a:avLst/>
@@ -3232,6 +3356,7 @@
           <a:lstStyle xmlns:a="http://schemas.openxmlformats.org/drawingml/2006/main"/>
           <a:p xmlns:a="http://schemas.openxmlformats.org/drawingml/2006/main">
             <a:pPr>
+              <a:buNone/>
               <a:defRPr sz="3000" b="1">
                 <a:solidFill>
                   <a:srgbClr val="183C3B"/>
@@ -3289,6 +3414,7 @@
           <a:lstStyle xmlns:a="http://schemas.openxmlformats.org/drawingml/2006/main"/>
           <a:p xmlns:a="http://schemas.openxmlformats.org/drawingml/2006/main">
             <a:pPr>
+              <a:buNone/>
               <a:defRPr sz="1050" b="0">
                 <a:solidFill>
                   <a:srgbClr val="6C7D82"/>
@@ -3307,7 +3433,7 @@
                 <a:ea typeface="Helvetica Neue"/>
                 <a:cs typeface="Helvetica Neue"/>
               </a:rPr>
-              <a:t>JobCompass    INT6181    4 / 5</a:t>
+              <a:t>Group 11    INT6181    4 / 5</a:t>
             </a:r>
           </a:p>
         </p:txBody>
@@ -3346,6 +3472,7 @@
           <a:lstStyle xmlns:a="http://schemas.openxmlformats.org/drawingml/2006/main"/>
           <a:p xmlns:a="http://schemas.openxmlformats.org/drawingml/2006/main">
             <a:pPr>
+              <a:buNone/>
               <a:defRPr sz="1950" b="0">
                 <a:solidFill>
                   <a:srgbClr val="6C7D82"/>
@@ -3371,7 +3498,7 @@
       </p:sp>
       <p:graphicFrame>
         <p:nvGraphicFramePr>
-          <p:cNvPr id="12" name="Chart"/>
+          <p:cNvPr id="14" name="Chart"/>
           <p:cNvGraphicFramePr/>
           <p:nvPr/>
         </p:nvGraphicFramePr>
@@ -3381,7 +3508,7 @@
         </p:xfrm>
         <a:graphic xmlns:a="http://schemas.openxmlformats.org/drawingml/2006/main">
           <a:graphicData uri="http://schemas.openxmlformats.org/drawingml/2006/chart">
-            <c:chart xmlns:r="http://schemas.openxmlformats.org/officeDocument/2006/relationships" xmlns:c="http://schemas.openxmlformats.org/drawingml/2006/chart" r:id="Re17e856070404942"/>
+            <c:chart xmlns:r="http://schemas.openxmlformats.org/officeDocument/2006/relationships" xmlns:c="http://schemas.openxmlformats.org/drawingml/2006/chart" r:id="R019b431b4c944db7"/>
           </a:graphicData>
         </a:graphic>
       </p:graphicFrame>
@@ -3419,6 +3546,7 @@
           <a:lstStyle xmlns:a="http://schemas.openxmlformats.org/drawingml/2006/main"/>
           <a:p xmlns:a="http://schemas.openxmlformats.org/drawingml/2006/main">
             <a:pPr>
+              <a:buNone/>
               <a:defRPr sz="2175" b="1">
                 <a:solidFill>
                   <a:srgbClr val="183C3B"/>
@@ -3476,6 +3604,7 @@
           <a:lstStyle xmlns:a="http://schemas.openxmlformats.org/drawingml/2006/main"/>
           <a:p xmlns:a="http://schemas.openxmlformats.org/drawingml/2006/main">
             <a:pPr>
+              <a:buNone/>
               <a:defRPr sz="1800" b="0">
                 <a:solidFill>
                   <a:srgbClr val="183C3B"/>
@@ -3499,6 +3628,7 @@
           </a:p>
           <a:p xmlns:a="http://schemas.openxmlformats.org/drawingml/2006/main">
             <a:pPr>
+              <a:buNone/>
               <a:defRPr sz="1800" b="0">
                 <a:solidFill>
                   <a:srgbClr val="183C3B"/>
@@ -3517,11 +3647,12 @@
                 <a:ea typeface="Helvetica Neue"/>
                 <a:cs typeface="Helvetica Neue"/>
               </a:rPr>
-              <a:t>Unknown requirements stay unknown.</a:t>
+              <a:t>Missing conditions reduce coverage.</a:t>
             </a:r>
           </a:p>
           <a:p xmlns:a="http://schemas.openxmlformats.org/drawingml/2006/main">
             <a:pPr>
+              <a:buNone/>
               <a:defRPr sz="1800" b="0">
                 <a:solidFill>
                   <a:srgbClr val="183C3B"/>
@@ -3540,7 +3671,7 @@
                 <a:ea typeface="Helvetica Neue"/>
                 <a:cs typeface="Helvetica Neue"/>
               </a:rPr>
-              <a:t>Remote does not mean worldwide.</a:t>
+              <a:t>Remote jobs can restrict location.</a:t>
             </a:r>
           </a:p>
         </p:txBody>
@@ -3579,6 +3710,7 @@
           <a:lstStyle xmlns:a="http://schemas.openxmlformats.org/drawingml/2006/main"/>
           <a:p xmlns:a="http://schemas.openxmlformats.org/drawingml/2006/main">
             <a:pPr>
+              <a:buNone/>
               <a:defRPr sz="1800" b="0">
                 <a:solidFill>
                   <a:srgbClr val="6C7D82"/>
@@ -3636,6 +3768,7 @@
           <a:lstStyle xmlns:a="http://schemas.openxmlformats.org/drawingml/2006/main"/>
           <a:p xmlns:a="http://schemas.openxmlformats.org/drawingml/2006/main">
             <a:pPr>
+              <a:buNone/>
               <a:defRPr sz="1650" b="0">
                 <a:solidFill>
                   <a:srgbClr val="6C7D82"/>
@@ -3654,7 +3787,7 @@
                 <a:ea typeface="Helvetica Neue"/>
                 <a:cs typeface="Helvetica Neue"/>
               </a:rPr>
-              <a:t>Scores are ranking indicators, not hiring probabilities.</a:t>
+              <a:t>Ranking scores require human interpretation.</a:t>
             </a:r>
           </a:p>
         </p:txBody>
@@ -3722,6 +3855,7 @@
           <a:lstStyle xmlns:a="http://schemas.openxmlformats.org/drawingml/2006/main"/>
           <a:p xmlns:a="http://schemas.openxmlformats.org/drawingml/2006/main">
             <a:pPr>
+              <a:buNone/>
               <a:defRPr sz="3000" b="1">
                 <a:solidFill>
                   <a:srgbClr val="183C3B"/>
@@ -3779,6 +3913,7 @@
           <a:lstStyle xmlns:a="http://schemas.openxmlformats.org/drawingml/2006/main"/>
           <a:p xmlns:a="http://schemas.openxmlformats.org/drawingml/2006/main">
             <a:pPr>
+              <a:buNone/>
               <a:defRPr sz="1050" b="0">
                 <a:solidFill>
                   <a:srgbClr val="6C7D82"/>
@@ -3797,7 +3932,7 @@
                 <a:ea typeface="Helvetica Neue"/>
                 <a:cs typeface="Helvetica Neue"/>
               </a:rPr>
-              <a:t>JobCompass    INT6181    5 / 5</a:t>
+              <a:t>Group 11    INT6181    5 / 5</a:t>
             </a:r>
           </a:p>
         </p:txBody>
@@ -3836,6 +3971,7 @@
           <a:lstStyle xmlns:a="http://schemas.openxmlformats.org/drawingml/2006/main"/>
           <a:p xmlns:a="http://schemas.openxmlformats.org/drawingml/2006/main">
             <a:pPr>
+              <a:buNone/>
               <a:defRPr sz="3150" b="1">
                 <a:solidFill>
                   <a:srgbClr val="087D75"/>
@@ -3854,7 +3990,7 @@
                 <a:ea typeface="Helvetica Neue"/>
                 <a:cs typeface="Helvetica Neue"/>
               </a:rPr>
-              <a:t>64 offline tests passed</a:t>
+              <a:t>71 local tests passed</a:t>
             </a:r>
           </a:p>
         </p:txBody>
@@ -3893,7 +4029,8 @@
           <a:lstStyle xmlns:a="http://schemas.openxmlformats.org/drawingml/2006/main"/>
           <a:p xmlns:a="http://schemas.openxmlformats.org/drawingml/2006/main">
             <a:pPr>
-              <a:defRPr sz="2025" b="0">
+              <a:buNone/>
+              <a:defRPr sz="1950" b="0">
                 <a:solidFill>
                   <a:srgbClr val="183C3B"/>
                 </a:solidFill>
@@ -3903,7 +4040,7 @@
               </a:defRPr>
             </a:pPr>
             <a:r>
-              <a:rPr sz="2025" b="0">
+              <a:rPr sz="1950" b="0">
                 <a:solidFill>
                   <a:srgbClr val="183C3B"/>
                 </a:solidFill>
@@ -3911,12 +4048,13 @@
                 <a:ea typeface="Helvetica Neue"/>
                 <a:cs typeface="Helvetica Neue"/>
               </a:rPr>
-              <a:t>Real collection and DeepSeek requests verified</a:t>
+              <a:t>6,910 research jobs ranked in 4.0517 seconds median</a:t>
             </a:r>
           </a:p>
           <a:p xmlns:a="http://schemas.openxmlformats.org/drawingml/2006/main">
             <a:pPr>
-              <a:defRPr sz="2025" b="0">
+              <a:buNone/>
+              <a:defRPr sz="1950" b="0">
                 <a:solidFill>
                   <a:srgbClr val="183C3B"/>
                 </a:solidFill>
@@ -3926,7 +4064,7 @@
               </a:defRPr>
             </a:pPr>
             <a:r>
-              <a:rPr sz="2025" b="0">
+              <a:rPr sz="1950" b="0">
                 <a:solidFill>
                   <a:srgbClr val="183C3B"/>
                 </a:solidFill>
@@ -3934,12 +4072,13 @@
                 <a:ea typeface="Helvetica Neue"/>
                 <a:cs typeface="Helvetica Neue"/>
               </a:rPr>
-              <a:t>1,200 sample jobs ranked in about 0.055 seconds</a:t>
+              <a:t>Three local runs with a fictional resume</a:t>
             </a:r>
           </a:p>
           <a:p xmlns:a="http://schemas.openxmlformats.org/drawingml/2006/main">
             <a:pPr>
-              <a:defRPr sz="2025" b="0">
+              <a:buNone/>
+              <a:defRPr sz="1950" b="0">
                 <a:solidFill>
                   <a:srgbClr val="183C3B"/>
                 </a:solidFill>
@@ -3949,7 +4088,7 @@
               </a:defRPr>
             </a:pPr>
             <a:r>
-              <a:rPr sz="2025" b="0">
+              <a:rPr sz="1950" b="0">
                 <a:solidFill>
                   <a:srgbClr val="183C3B"/>
                 </a:solidFill>
@@ -3957,7 +4096,7 @@
                 <a:ea typeface="Helvetica Neue"/>
                 <a:cs typeface="Helvetica Neue"/>
               </a:rPr>
-              <a:t>Precision@4 = 1.0 on 12 synthetic labelled jobs</a:t>
+              <a:t>No human relevance labels for the research snapshot</a:t>
             </a:r>
           </a:p>
         </p:txBody>
@@ -3996,6 +4135,7 @@
           <a:lstStyle xmlns:a="http://schemas.openxmlformats.org/drawingml/2006/main"/>
           <a:p xmlns:a="http://schemas.openxmlformats.org/drawingml/2006/main">
             <a:pPr>
+              <a:buNone/>
               <a:defRPr sz="2100" b="1">
                 <a:solidFill>
                   <a:srgbClr val="183C3B"/>
@@ -4053,6 +4193,7 @@
           <a:lstStyle xmlns:a="http://schemas.openxmlformats.org/drawingml/2006/main"/>
           <a:p xmlns:a="http://schemas.openxmlformats.org/drawingml/2006/main">
             <a:pPr>
+              <a:buNone/>
               <a:defRPr sz="1725" b="0">
                 <a:solidFill>
                   <a:srgbClr val="6C7D82"/>
@@ -4071,7 +4212,7 @@
                 <a:ea typeface="Helvetica Neue"/>
                 <a:cs typeface="Helvetica Neue"/>
               </a:rPr>
-              <a:t>Tests verify specified behavior. Synthetic labels do not establish real hiring accuracy. Cloud CI is configured but has not run.</a:t>
+              <a:t>Tests check behavior. The benchmark measures runtime. Real-data accuracy remains unmeasured.</a:t>
             </a:r>
           </a:p>
         </p:txBody>
@@ -4110,6 +4251,7 @@
           <a:lstStyle xmlns:a="http://schemas.openxmlformats.org/drawingml/2006/main"/>
           <a:p xmlns:a="http://schemas.openxmlformats.org/drawingml/2006/main">
             <a:pPr>
+              <a:buNone/>
               <a:defRPr sz="2100" b="1">
                 <a:solidFill>
                   <a:srgbClr val="183C3B"/>
@@ -4167,6 +4309,7 @@
           <a:lstStyle xmlns:a="http://schemas.openxmlformats.org/drawingml/2006/main"/>
           <a:p xmlns:a="http://schemas.openxmlformats.org/drawingml/2006/main">
             <a:pPr>
+              <a:buNone/>
               <a:defRPr sz="1725" b="0">
                 <a:solidFill>
                   <a:srgbClr val="6C7D82"/>
@@ -4185,7 +4328,7 @@
                 <a:ea typeface="Helvetica Neue"/>
                 <a:cs typeface="Helvetica Neue"/>
               </a:rPr>
-              <a:t>Load a resume, inspect score components, generate an AI draft and move a saved job to the application board.</a:t>
+              <a:t>Show resume evidence, a score breakdown and the application board. AI assistance is disclosed.</a:t>
             </a:r>
           </a:p>
         </p:txBody>

</xml_diff>